<commit_message>
Release v0.2.0a2 with synthetic Palette Fusion example
</commit_message>
<xml_diff>
--- a/evals/previews/bisr-rnaseq-workflow/bisr-rnaseq-workflow.pptx
+++ b/evals/previews/bisr-rnaseq-workflow/bisr-rnaseq-workflow.pptx
@@ -2,13 +2,13 @@
 <file path=ppt/presentation.xml><?xml version="1.0" encoding="utf-8"?>
 <p:presentation xmlns:p="http://schemas.openxmlformats.org/presentationml/2006/main">
   <p:sldMasterIdLst>
-    <p:sldMasterId xmlns:r="http://schemas.openxmlformats.org/officeDocument/2006/relationships" id="2147483648" r:id="Rf69bc8cbc3a24986"/>
+    <p:sldMasterId xmlns:r="http://schemas.openxmlformats.org/officeDocument/2006/relationships" id="2147483648" r:id="R23e67870904a430c"/>
   </p:sldMasterIdLst>
   <p:notesMasterIdLst>
-    <p:notesMasterId xmlns:r="http://schemas.openxmlformats.org/officeDocument/2006/relationships" r:id="R71a76ee3d9b5400d"/>
+    <p:notesMasterId xmlns:r="http://schemas.openxmlformats.org/officeDocument/2006/relationships" r:id="R59e84f7f514a4286"/>
   </p:notesMasterIdLst>
   <p:sldIdLst>
-    <p:sldId xmlns:r="http://schemas.openxmlformats.org/officeDocument/2006/relationships" id="256" r:id="R93a355cc748741ec"/>
+    <p:sldId xmlns:r="http://schemas.openxmlformats.org/officeDocument/2006/relationships" id="256" r:id="Rab3bd0cea10741bc"/>
   </p:sldIdLst>
   <p:sldSz cx="42805350" cy="30279975"/>
   <p:notesSz cx="6858000" cy="9144000"/>
@@ -525,7 +525,7 @@
   </p:cSld>
   <p:clrMap bg1="lt1" tx1="dk1" bg2="lt2" tx2="dk2" accent1="accent1" accent2="accent2" accent3="accent3" accent4="accent4" accent5="accent5" accent6="accent6" hlink="hlink" folHlink="folHlink"/>
   <p:sldLayoutIdLst>
-    <p:sldLayoutId xmlns:r="http://schemas.openxmlformats.org/officeDocument/2006/relationships" id="2147483649" r:id="Rb69a6e6e69224690"/>
+    <p:sldLayoutId xmlns:r="http://schemas.openxmlformats.org/officeDocument/2006/relationships" id="2147483649" r:id="Rf7c908aef52d456a"/>
   </p:sldLayoutIdLst>
   <p:txStyles>
     <p:titleStyle>
@@ -1076,7 +1076,7 @@
           <p:cNvPr id="92" name="header-band">
             <a:extLst xmlns:a="http://schemas.openxmlformats.org/drawingml/2006/main">
               <a:ext uri="{FF2B5EF4-FFF2-40B4-BE49-F238E27FC236}">
-                <a16:creationId xmlns:a16="http://schemas.microsoft.com/office/drawing/2014/main" id="{C1E25709-FF89-46A8-BC5C-A75D3A81F3C1}"/>
+                <a16:creationId xmlns:a16="http://schemas.microsoft.com/office/drawing/2014/main" id="{F981768E-8329-4600-96B1-F9B6F6D398A2}"/>
               </a:ext>
             </a:extLst>
           </p:cNvPr>
@@ -1109,7 +1109,7 @@
           <p:cNvPr id="2" name="top-accent">
             <a:extLst xmlns:a="http://schemas.openxmlformats.org/drawingml/2006/main">
               <a:ext uri="{FF2B5EF4-FFF2-40B4-BE49-F238E27FC236}">
-                <a16:creationId xmlns:a16="http://schemas.microsoft.com/office/drawing/2014/main" id="{FF67D830-3B6A-4CBE-90C9-02856721A530}"/>
+                <a16:creationId xmlns:a16="http://schemas.microsoft.com/office/drawing/2014/main" id="{328AEC8B-F971-4574-ADF1-1A26711BE119}"/>
               </a:ext>
             </a:extLst>
           </p:cNvPr>
@@ -1142,7 +1142,7 @@
           <p:cNvPr id="3" name="poster-title">
             <a:extLst xmlns:a="http://schemas.openxmlformats.org/drawingml/2006/main">
               <a:ext uri="{FF2B5EF4-FFF2-40B4-BE49-F238E27FC236}">
-                <a16:creationId xmlns:a16="http://schemas.microsoft.com/office/drawing/2014/main" id="{215E385E-77CA-4C68-B761-A0648C0D2CDC}"/>
+                <a16:creationId xmlns:a16="http://schemas.microsoft.com/office/drawing/2014/main" id="{E74D1314-4768-46C6-8C57-837C13F170D6}"/>
               </a:ext>
             </a:extLst>
           </p:cNvPr>
@@ -1192,7 +1192,7 @@
           <p:cNvPr id="4" name="authors">
             <a:extLst xmlns:a="http://schemas.openxmlformats.org/drawingml/2006/main">
               <a:ext uri="{FF2B5EF4-FFF2-40B4-BE49-F238E27FC236}">
-                <a16:creationId xmlns:a16="http://schemas.microsoft.com/office/drawing/2014/main" id="{59C27950-A6EB-4EC7-91A6-4F239E52E605}"/>
+                <a16:creationId xmlns:a16="http://schemas.microsoft.com/office/drawing/2014/main" id="{6C5BD845-7E34-4864-9298-20D9A8FA814C}"/>
               </a:ext>
             </a:extLst>
           </p:cNvPr>
@@ -1242,7 +1242,7 @@
           <p:cNvPr id="5" name="affiliations">
             <a:extLst xmlns:a="http://schemas.openxmlformats.org/drawingml/2006/main">
               <a:ext uri="{FF2B5EF4-FFF2-40B4-BE49-F238E27FC236}">
-                <a16:creationId xmlns:a16="http://schemas.microsoft.com/office/drawing/2014/main" id="{A5B058CA-36CA-4DA8-B049-0EA05E43CBAE}"/>
+                <a16:creationId xmlns:a16="http://schemas.microsoft.com/office/drawing/2014/main" id="{AC8942EF-206D-4125-B484-6604BB13DB36}"/>
               </a:ext>
             </a:extLst>
           </p:cNvPr>
@@ -1292,7 +1292,7 @@
           <p:cNvPr id="6" name="citation">
             <a:extLst xmlns:a="http://schemas.openxmlformats.org/drawingml/2006/main">
               <a:ext uri="{FF2B5EF4-FFF2-40B4-BE49-F238E27FC236}">
-                <a16:creationId xmlns:a16="http://schemas.microsoft.com/office/drawing/2014/main" id="{9F6E5DC7-D6EC-413E-9993-992CC4DBE077}"/>
+                <a16:creationId xmlns:a16="http://schemas.microsoft.com/office/drawing/2014/main" id="{B683D5CA-24AC-49A6-B5C6-D323A5C30395}"/>
               </a:ext>
             </a:extLst>
           </p:cNvPr>
@@ -1342,7 +1342,7 @@
           <p:cNvPr id="7" name="logo-slot-institution-logo">
             <a:extLst xmlns:a="http://schemas.openxmlformats.org/drawingml/2006/main">
               <a:ext uri="{FF2B5EF4-FFF2-40B4-BE49-F238E27FC236}">
-                <a16:creationId xmlns:a16="http://schemas.microsoft.com/office/drawing/2014/main" id="{C7F8F383-693D-4B72-88C7-19D9D03954AE}"/>
+                <a16:creationId xmlns:a16="http://schemas.microsoft.com/office/drawing/2014/main" id="{2C115371-AC10-4879-A60A-4AC883A69959}"/>
               </a:ext>
             </a:extLst>
           </p:cNvPr>
@@ -1377,7 +1377,7 @@
           <p:cNvPr id="8" name="logo-placeholder-institution-logo">
             <a:extLst xmlns:a="http://schemas.openxmlformats.org/drawingml/2006/main">
               <a:ext uri="{FF2B5EF4-FFF2-40B4-BE49-F238E27FC236}">
-                <a16:creationId xmlns:a16="http://schemas.microsoft.com/office/drawing/2014/main" id="{CF3C65B8-1BCA-4833-B1E2-9B7C89FF9573}"/>
+                <a16:creationId xmlns:a16="http://schemas.microsoft.com/office/drawing/2014/main" id="{7BED3E60-7E80-412B-8934-518A4CEA6836}"/>
               </a:ext>
             </a:extLst>
           </p:cNvPr>
@@ -1427,7 +1427,7 @@
           <p:cNvPr id="9" name="header-summary">
             <a:extLst xmlns:a="http://schemas.openxmlformats.org/drawingml/2006/main">
               <a:ext uri="{FF2B5EF4-FFF2-40B4-BE49-F238E27FC236}">
-                <a16:creationId xmlns:a16="http://schemas.microsoft.com/office/drawing/2014/main" id="{4D8E0951-49E4-4483-B733-2B5630D505D8}"/>
+                <a16:creationId xmlns:a16="http://schemas.microsoft.com/office/drawing/2014/main" id="{A9014C42-4244-4BD9-A608-8F4532EC0915}"/>
               </a:ext>
             </a:extLst>
           </p:cNvPr>
@@ -1460,7 +1460,7 @@
           <p:cNvPr id="10" name="header-metric-1-value">
             <a:extLst xmlns:a="http://schemas.openxmlformats.org/drawingml/2006/main">
               <a:ext uri="{FF2B5EF4-FFF2-40B4-BE49-F238E27FC236}">
-                <a16:creationId xmlns:a16="http://schemas.microsoft.com/office/drawing/2014/main" id="{A51EA1ED-3C96-40B2-99BD-7050AE20A679}"/>
+                <a16:creationId xmlns:a16="http://schemas.microsoft.com/office/drawing/2014/main" id="{C36FBCC2-9EC3-492F-BAD6-21CD9A67DFD2}"/>
               </a:ext>
             </a:extLst>
           </p:cNvPr>
@@ -1510,7 +1510,7 @@
           <p:cNvPr id="11" name="header-metric-1-label">
             <a:extLst xmlns:a="http://schemas.openxmlformats.org/drawingml/2006/main">
               <a:ext uri="{FF2B5EF4-FFF2-40B4-BE49-F238E27FC236}">
-                <a16:creationId xmlns:a16="http://schemas.microsoft.com/office/drawing/2014/main" id="{B9D8E766-A3E4-4270-A205-669DF08029CC}"/>
+                <a16:creationId xmlns:a16="http://schemas.microsoft.com/office/drawing/2014/main" id="{BB2687EC-4816-4887-BC50-B129E4ECA1D2}"/>
               </a:ext>
             </a:extLst>
           </p:cNvPr>
@@ -1560,7 +1560,7 @@
           <p:cNvPr id="12" name="header-metric-2-value">
             <a:extLst xmlns:a="http://schemas.openxmlformats.org/drawingml/2006/main">
               <a:ext uri="{FF2B5EF4-FFF2-40B4-BE49-F238E27FC236}">
-                <a16:creationId xmlns:a16="http://schemas.microsoft.com/office/drawing/2014/main" id="{A7294702-9EE1-4BF5-89E1-69DE849D9F5D}"/>
+                <a16:creationId xmlns:a16="http://schemas.microsoft.com/office/drawing/2014/main" id="{778C4F4B-45A6-4BBB-BDEE-2C602ACC5734}"/>
               </a:ext>
             </a:extLst>
           </p:cNvPr>
@@ -1610,7 +1610,7 @@
           <p:cNvPr id="13" name="header-metric-2-label">
             <a:extLst xmlns:a="http://schemas.openxmlformats.org/drawingml/2006/main">
               <a:ext uri="{FF2B5EF4-FFF2-40B4-BE49-F238E27FC236}">
-                <a16:creationId xmlns:a16="http://schemas.microsoft.com/office/drawing/2014/main" id="{CC552602-52B9-4846-8F6A-7B97164B6806}"/>
+                <a16:creationId xmlns:a16="http://schemas.microsoft.com/office/drawing/2014/main" id="{8C35E728-A0D6-42C9-ACB0-C4D6AE8D76AA}"/>
               </a:ext>
             </a:extLst>
           </p:cNvPr>
@@ -1660,7 +1660,7 @@
           <p:cNvPr id="14" name="header-metric-3-value">
             <a:extLst xmlns:a="http://schemas.openxmlformats.org/drawingml/2006/main">
               <a:ext uri="{FF2B5EF4-FFF2-40B4-BE49-F238E27FC236}">
-                <a16:creationId xmlns:a16="http://schemas.microsoft.com/office/drawing/2014/main" id="{87901887-2805-41AE-8CDF-A00C5A037C76}"/>
+                <a16:creationId xmlns:a16="http://schemas.microsoft.com/office/drawing/2014/main" id="{5A461B45-9656-4EC3-90B8-AFB6B8DEDD45}"/>
               </a:ext>
             </a:extLst>
           </p:cNvPr>
@@ -1710,7 +1710,7 @@
           <p:cNvPr id="15" name="header-metric-3-label">
             <a:extLst xmlns:a="http://schemas.openxmlformats.org/drawingml/2006/main">
               <a:ext uri="{FF2B5EF4-FFF2-40B4-BE49-F238E27FC236}">
-                <a16:creationId xmlns:a16="http://schemas.microsoft.com/office/drawing/2014/main" id="{5CB84C1E-3D8B-41D3-B9EC-81141E670888}"/>
+                <a16:creationId xmlns:a16="http://schemas.microsoft.com/office/drawing/2014/main" id="{24B6E4F9-95E2-46AC-9A36-C8A3AFA0698E}"/>
               </a:ext>
             </a:extLst>
           </p:cNvPr>
@@ -1760,7 +1760,7 @@
           <p:cNvPr id="16" name="question-title">
             <a:extLst xmlns:a="http://schemas.openxmlformats.org/drawingml/2006/main">
               <a:ext uri="{FF2B5EF4-FFF2-40B4-BE49-F238E27FC236}">
-                <a16:creationId xmlns:a16="http://schemas.microsoft.com/office/drawing/2014/main" id="{1AD63B20-BAF5-4F1E-8282-796D77A7DE4F}"/>
+                <a16:creationId xmlns:a16="http://schemas.microsoft.com/office/drawing/2014/main" id="{7731F396-6F36-4FCA-93A6-C83127695A31}"/>
               </a:ext>
             </a:extLst>
           </p:cNvPr>
@@ -1810,7 +1810,7 @@
           <p:cNvPr id="17" name="question-rule">
             <a:extLst xmlns:a="http://schemas.openxmlformats.org/drawingml/2006/main">
               <a:ext uri="{FF2B5EF4-FFF2-40B4-BE49-F238E27FC236}">
-                <a16:creationId xmlns:a16="http://schemas.microsoft.com/office/drawing/2014/main" id="{6AF48AFA-5C13-47EB-9405-00294D5EBABC}"/>
+                <a16:creationId xmlns:a16="http://schemas.microsoft.com/office/drawing/2014/main" id="{004D4A5A-367E-452B-BE90-70FD44930680}"/>
               </a:ext>
             </a:extLst>
           </p:cNvPr>
@@ -1843,7 +1843,7 @@
           <p:cNvPr id="18" name="research-question">
             <a:extLst xmlns:a="http://schemas.openxmlformats.org/drawingml/2006/main">
               <a:ext uri="{FF2B5EF4-FFF2-40B4-BE49-F238E27FC236}">
-                <a16:creationId xmlns:a16="http://schemas.microsoft.com/office/drawing/2014/main" id="{4E123635-82F1-46DF-8E42-3EF4BE3DB62E}"/>
+                <a16:creationId xmlns:a16="http://schemas.microsoft.com/office/drawing/2014/main" id="{0EC6F584-CC5A-4C78-93BC-FE325EB5808C}"/>
               </a:ext>
             </a:extLst>
           </p:cNvPr>
@@ -1893,7 +1893,7 @@
           <p:cNvPr id="19" name="question-evidence">
             <a:extLst xmlns:a="http://schemas.openxmlformats.org/drawingml/2006/main">
               <a:ext uri="{FF2B5EF4-FFF2-40B4-BE49-F238E27FC236}">
-                <a16:creationId xmlns:a16="http://schemas.microsoft.com/office/drawing/2014/main" id="{B385477A-F1E0-439B-BD0E-DDAF52CBFD8F}"/>
+                <a16:creationId xmlns:a16="http://schemas.microsoft.com/office/drawing/2014/main" id="{B750A705-D1C7-44C5-AAD9-BAE7BBDE2130}"/>
               </a:ext>
             </a:extLst>
           </p:cNvPr>
@@ -1943,7 +1943,7 @@
           <p:cNvPr id="20" name="pipeline-title">
             <a:extLst xmlns:a="http://schemas.openxmlformats.org/drawingml/2006/main">
               <a:ext uri="{FF2B5EF4-FFF2-40B4-BE49-F238E27FC236}">
-                <a16:creationId xmlns:a16="http://schemas.microsoft.com/office/drawing/2014/main" id="{DC2905FE-E879-4187-ACE7-B6D6B47B8CE9}"/>
+                <a16:creationId xmlns:a16="http://schemas.microsoft.com/office/drawing/2014/main" id="{8B87B353-E948-46C1-91D2-B2F1470D8109}"/>
               </a:ext>
             </a:extLst>
           </p:cNvPr>
@@ -1993,7 +1993,7 @@
           <p:cNvPr id="21" name="pipeline-rule">
             <a:extLst xmlns:a="http://schemas.openxmlformats.org/drawingml/2006/main">
               <a:ext uri="{FF2B5EF4-FFF2-40B4-BE49-F238E27FC236}">
-                <a16:creationId xmlns:a16="http://schemas.microsoft.com/office/drawing/2014/main" id="{9FD41CC1-8AAD-452D-AE19-C15B72867380}"/>
+                <a16:creationId xmlns:a16="http://schemas.microsoft.com/office/drawing/2014/main" id="{9B2F815E-5AF4-41F8-9FCB-9F82016FD823}"/>
               </a:ext>
             </a:extLst>
           </p:cNvPr>
@@ -2026,7 +2026,7 @@
           <p:cNvPr id="22" name="pipeline-1-number-bg">
             <a:extLst xmlns:a="http://schemas.openxmlformats.org/drawingml/2006/main">
               <a:ext uri="{FF2B5EF4-FFF2-40B4-BE49-F238E27FC236}">
-                <a16:creationId xmlns:a16="http://schemas.microsoft.com/office/drawing/2014/main" id="{22CC8462-F899-47F3-985A-42798A02C816}"/>
+                <a16:creationId xmlns:a16="http://schemas.microsoft.com/office/drawing/2014/main" id="{B6D963C0-B602-43C5-B61A-E1992FFD13F7}"/>
               </a:ext>
             </a:extLst>
           </p:cNvPr>
@@ -2059,7 +2059,7 @@
           <p:cNvPr id="23" name="pipeline-1-number">
             <a:extLst xmlns:a="http://schemas.openxmlformats.org/drawingml/2006/main">
               <a:ext uri="{FF2B5EF4-FFF2-40B4-BE49-F238E27FC236}">
-                <a16:creationId xmlns:a16="http://schemas.microsoft.com/office/drawing/2014/main" id="{E8E4B864-E455-42DF-9772-ED930F0AC7B4}"/>
+                <a16:creationId xmlns:a16="http://schemas.microsoft.com/office/drawing/2014/main" id="{449D2B86-1AC6-4EBB-BA52-12B3FDDCEBAC}"/>
               </a:ext>
             </a:extLst>
           </p:cNvPr>
@@ -2109,7 +2109,7 @@
           <p:cNvPr id="24" name="pipeline-1-text">
             <a:extLst xmlns:a="http://schemas.openxmlformats.org/drawingml/2006/main">
               <a:ext uri="{FF2B5EF4-FFF2-40B4-BE49-F238E27FC236}">
-                <a16:creationId xmlns:a16="http://schemas.microsoft.com/office/drawing/2014/main" id="{14FBBEAB-F29D-41C0-9568-DA18F5C46E02}"/>
+                <a16:creationId xmlns:a16="http://schemas.microsoft.com/office/drawing/2014/main" id="{638B9453-ED9B-48EA-8523-FE41D6C6FED8}"/>
               </a:ext>
             </a:extLst>
           </p:cNvPr>
@@ -2159,7 +2159,7 @@
           <p:cNvPr id="25" name="pipeline-2-number-bg">
             <a:extLst xmlns:a="http://schemas.openxmlformats.org/drawingml/2006/main">
               <a:ext uri="{FF2B5EF4-FFF2-40B4-BE49-F238E27FC236}">
-                <a16:creationId xmlns:a16="http://schemas.microsoft.com/office/drawing/2014/main" id="{150872FF-2517-4B1C-9982-5A236A981E9B}"/>
+                <a16:creationId xmlns:a16="http://schemas.microsoft.com/office/drawing/2014/main" id="{91B5CC8B-96FE-449B-99EC-D68A35274E25}"/>
               </a:ext>
             </a:extLst>
           </p:cNvPr>
@@ -2192,7 +2192,7 @@
           <p:cNvPr id="26" name="pipeline-2-number">
             <a:extLst xmlns:a="http://schemas.openxmlformats.org/drawingml/2006/main">
               <a:ext uri="{FF2B5EF4-FFF2-40B4-BE49-F238E27FC236}">
-                <a16:creationId xmlns:a16="http://schemas.microsoft.com/office/drawing/2014/main" id="{559C4300-BB45-434B-B938-8011686F317B}"/>
+                <a16:creationId xmlns:a16="http://schemas.microsoft.com/office/drawing/2014/main" id="{BFC357DB-8F83-4577-AA38-507508DCF184}"/>
               </a:ext>
             </a:extLst>
           </p:cNvPr>
@@ -2242,7 +2242,7 @@
           <p:cNvPr id="27" name="pipeline-2-text">
             <a:extLst xmlns:a="http://schemas.openxmlformats.org/drawingml/2006/main">
               <a:ext uri="{FF2B5EF4-FFF2-40B4-BE49-F238E27FC236}">
-                <a16:creationId xmlns:a16="http://schemas.microsoft.com/office/drawing/2014/main" id="{795126AD-8AF5-4E96-8BAD-21D24941CEBC}"/>
+                <a16:creationId xmlns:a16="http://schemas.microsoft.com/office/drawing/2014/main" id="{0562BF99-41FE-4646-8547-81221D3CB5A1}"/>
               </a:ext>
             </a:extLst>
           </p:cNvPr>
@@ -2292,7 +2292,7 @@
           <p:cNvPr id="28" name="pipeline-3-number-bg">
             <a:extLst xmlns:a="http://schemas.openxmlformats.org/drawingml/2006/main">
               <a:ext uri="{FF2B5EF4-FFF2-40B4-BE49-F238E27FC236}">
-                <a16:creationId xmlns:a16="http://schemas.microsoft.com/office/drawing/2014/main" id="{8C679E7B-8509-406F-83EF-7E13405348C5}"/>
+                <a16:creationId xmlns:a16="http://schemas.microsoft.com/office/drawing/2014/main" id="{C485767A-8F19-4BF6-A4D5-AAE7D9B135EA}"/>
               </a:ext>
             </a:extLst>
           </p:cNvPr>
@@ -2325,7 +2325,7 @@
           <p:cNvPr id="29" name="pipeline-3-number">
             <a:extLst xmlns:a="http://schemas.openxmlformats.org/drawingml/2006/main">
               <a:ext uri="{FF2B5EF4-FFF2-40B4-BE49-F238E27FC236}">
-                <a16:creationId xmlns:a16="http://schemas.microsoft.com/office/drawing/2014/main" id="{826ACC4A-A1F1-4F68-A3DA-1DA6A82C15B1}"/>
+                <a16:creationId xmlns:a16="http://schemas.microsoft.com/office/drawing/2014/main" id="{6C1FB792-3D01-49B6-81D2-F484EFBF42B5}"/>
               </a:ext>
             </a:extLst>
           </p:cNvPr>
@@ -2375,7 +2375,7 @@
           <p:cNvPr id="30" name="pipeline-3-text">
             <a:extLst xmlns:a="http://schemas.openxmlformats.org/drawingml/2006/main">
               <a:ext uri="{FF2B5EF4-FFF2-40B4-BE49-F238E27FC236}">
-                <a16:creationId xmlns:a16="http://schemas.microsoft.com/office/drawing/2014/main" id="{5A323F4F-7268-416D-9719-5796C0EC7B0F}"/>
+                <a16:creationId xmlns:a16="http://schemas.microsoft.com/office/drawing/2014/main" id="{97B44BD3-F174-4487-9BB7-F50AE80F6875}"/>
               </a:ext>
             </a:extLst>
           </p:cNvPr>
@@ -2425,7 +2425,7 @@
           <p:cNvPr id="31" name="pipeline-4-number-bg">
             <a:extLst xmlns:a="http://schemas.openxmlformats.org/drawingml/2006/main">
               <a:ext uri="{FF2B5EF4-FFF2-40B4-BE49-F238E27FC236}">
-                <a16:creationId xmlns:a16="http://schemas.microsoft.com/office/drawing/2014/main" id="{B86126C1-A58A-4C88-972C-0EAC20E853EE}"/>
+                <a16:creationId xmlns:a16="http://schemas.microsoft.com/office/drawing/2014/main" id="{EAE7B9FB-B33F-4FB1-B559-AAB4CC401914}"/>
               </a:ext>
             </a:extLst>
           </p:cNvPr>
@@ -2458,7 +2458,7 @@
           <p:cNvPr id="32" name="pipeline-4-number">
             <a:extLst xmlns:a="http://schemas.openxmlformats.org/drawingml/2006/main">
               <a:ext uri="{FF2B5EF4-FFF2-40B4-BE49-F238E27FC236}">
-                <a16:creationId xmlns:a16="http://schemas.microsoft.com/office/drawing/2014/main" id="{31198151-966D-4A3E-93FE-D177D988EEED}"/>
+                <a16:creationId xmlns:a16="http://schemas.microsoft.com/office/drawing/2014/main" id="{E446F215-F198-48DB-8FBB-56C492391DCE}"/>
               </a:ext>
             </a:extLst>
           </p:cNvPr>
@@ -2508,7 +2508,7 @@
           <p:cNvPr id="33" name="pipeline-4-text">
             <a:extLst xmlns:a="http://schemas.openxmlformats.org/drawingml/2006/main">
               <a:ext uri="{FF2B5EF4-FFF2-40B4-BE49-F238E27FC236}">
-                <a16:creationId xmlns:a16="http://schemas.microsoft.com/office/drawing/2014/main" id="{5089183F-270F-4737-A5B2-B1E2264FB094}"/>
+                <a16:creationId xmlns:a16="http://schemas.microsoft.com/office/drawing/2014/main" id="{D32182E7-F293-49D4-A3B1-EA9222E1ED65}"/>
               </a:ext>
             </a:extLst>
           </p:cNvPr>
@@ -2558,7 +2558,7 @@
           <p:cNvPr id="34" name="dataset-panel">
             <a:extLst xmlns:a="http://schemas.openxmlformats.org/drawingml/2006/main">
               <a:ext uri="{FF2B5EF4-FFF2-40B4-BE49-F238E27FC236}">
-                <a16:creationId xmlns:a16="http://schemas.microsoft.com/office/drawing/2014/main" id="{18CD2DE3-B37F-496F-8C1E-9CBB4DF57DCF}"/>
+                <a16:creationId xmlns:a16="http://schemas.microsoft.com/office/drawing/2014/main" id="{CDB5C55E-3C65-4F8F-97D9-8A243203F96C}"/>
               </a:ext>
             </a:extLst>
           </p:cNvPr>
@@ -2593,7 +2593,7 @@
           <p:cNvPr id="35" name="dataset-kicker">
             <a:extLst xmlns:a="http://schemas.openxmlformats.org/drawingml/2006/main">
               <a:ext uri="{FF2B5EF4-FFF2-40B4-BE49-F238E27FC236}">
-                <a16:creationId xmlns:a16="http://schemas.microsoft.com/office/drawing/2014/main" id="{C5B42EEE-0F0D-4AFF-94D5-A61EC3D39D0E}"/>
+                <a16:creationId xmlns:a16="http://schemas.microsoft.com/office/drawing/2014/main" id="{A2BE0721-3881-423C-BAA0-CAFFA529DEEB}"/>
               </a:ext>
             </a:extLst>
           </p:cNvPr>
@@ -2643,7 +2643,7 @@
           <p:cNvPr id="36" name="datasets">
             <a:extLst xmlns:a="http://schemas.openxmlformats.org/drawingml/2006/main">
               <a:ext uri="{FF2B5EF4-FFF2-40B4-BE49-F238E27FC236}">
-                <a16:creationId xmlns:a16="http://schemas.microsoft.com/office/drawing/2014/main" id="{A07E240C-A76F-4086-8C14-5BFB07511A33}"/>
+                <a16:creationId xmlns:a16="http://schemas.microsoft.com/office/drawing/2014/main" id="{FBACEB52-17B8-431F-BB3D-4AD8FEADDE41}"/>
               </a:ext>
             </a:extLst>
           </p:cNvPr>
@@ -2744,7 +2744,7 @@
           <p:cNvPr id="37" name="dataset-evidence">
             <a:extLst xmlns:a="http://schemas.openxmlformats.org/drawingml/2006/main">
               <a:ext uri="{FF2B5EF4-FFF2-40B4-BE49-F238E27FC236}">
-                <a16:creationId xmlns:a16="http://schemas.microsoft.com/office/drawing/2014/main" id="{35B8B8BE-63F2-4C91-8AD8-07AFEF3CDD92}"/>
+                <a16:creationId xmlns:a16="http://schemas.microsoft.com/office/drawing/2014/main" id="{78B4637B-86E0-41FE-8FF7-CC5B7E919C46}"/>
               </a:ext>
             </a:extLst>
           </p:cNvPr>
@@ -2794,7 +2794,7 @@
           <p:cNvPr id="38" name="figure-one-heading-title">
             <a:extLst xmlns:a="http://schemas.openxmlformats.org/drawingml/2006/main">
               <a:ext uri="{FF2B5EF4-FFF2-40B4-BE49-F238E27FC236}">
-                <a16:creationId xmlns:a16="http://schemas.microsoft.com/office/drawing/2014/main" id="{C945C03B-0198-4B67-861A-834921989C3A}"/>
+                <a16:creationId xmlns:a16="http://schemas.microsoft.com/office/drawing/2014/main" id="{DB3B186F-9129-49FE-AF6A-EA9DDDF5B487}"/>
               </a:ext>
             </a:extLst>
           </p:cNvPr>
@@ -2844,7 +2844,7 @@
           <p:cNvPr id="39" name="figure-one-heading-rule">
             <a:extLst xmlns:a="http://schemas.openxmlformats.org/drawingml/2006/main">
               <a:ext uri="{FF2B5EF4-FFF2-40B4-BE49-F238E27FC236}">
-                <a16:creationId xmlns:a16="http://schemas.microsoft.com/office/drawing/2014/main" id="{B0394B9C-C15B-4B2C-8DE3-69DF695A6AE3}"/>
+                <a16:creationId xmlns:a16="http://schemas.microsoft.com/office/drawing/2014/main" id="{3F8ADD8C-327C-480B-B113-7CA86F3717C9}"/>
               </a:ext>
             </a:extLst>
           </p:cNvPr>
@@ -2877,7 +2877,7 @@
           <p:cNvPr id="40" name="figure-one-frame">
             <a:extLst xmlns:a="http://schemas.openxmlformats.org/drawingml/2006/main">
               <a:ext uri="{FF2B5EF4-FFF2-40B4-BE49-F238E27FC236}">
-                <a16:creationId xmlns:a16="http://schemas.microsoft.com/office/drawing/2014/main" id="{36D96ACD-7E91-4F58-BF94-A28D478215FE}"/>
+                <a16:creationId xmlns:a16="http://schemas.microsoft.com/office/drawing/2014/main" id="{04618E49-F0D4-47FF-AFC9-89B98771A5C4}"/>
               </a:ext>
             </a:extLst>
           </p:cNvPr>
@@ -2912,7 +2912,7 @@
           <p:cNvPr id="41" name="figure-one-placeholder">
             <a:extLst xmlns:a="http://schemas.openxmlformats.org/drawingml/2006/main">
               <a:ext uri="{FF2B5EF4-FFF2-40B4-BE49-F238E27FC236}">
-                <a16:creationId xmlns:a16="http://schemas.microsoft.com/office/drawing/2014/main" id="{753886D4-CAC4-4573-A593-C086660A4FA8}"/>
+                <a16:creationId xmlns:a16="http://schemas.microsoft.com/office/drawing/2014/main" id="{01F4EA40-22D3-468D-8D8B-E961700DB1E5}"/>
               </a:ext>
             </a:extLst>
           </p:cNvPr>
@@ -2947,7 +2947,7 @@
           <p:cNvPr id="42" name="figure-one-placeholder-label">
             <a:extLst xmlns:a="http://schemas.openxmlformats.org/drawingml/2006/main">
               <a:ext uri="{FF2B5EF4-FFF2-40B4-BE49-F238E27FC236}">
-                <a16:creationId xmlns:a16="http://schemas.microsoft.com/office/drawing/2014/main" id="{979F9D25-37F1-4B9D-AC8A-BCFA93796A3F}"/>
+                <a16:creationId xmlns:a16="http://schemas.microsoft.com/office/drawing/2014/main" id="{36B73C0A-754A-4A00-9C7F-BEA9C5B24D1E}"/>
               </a:ext>
             </a:extLst>
           </p:cNvPr>
@@ -2997,7 +2997,7 @@
           <p:cNvPr id="43" name="figure-one-caption">
             <a:extLst xmlns:a="http://schemas.openxmlformats.org/drawingml/2006/main">
               <a:ext uri="{FF2B5EF4-FFF2-40B4-BE49-F238E27FC236}">
-                <a16:creationId xmlns:a16="http://schemas.microsoft.com/office/drawing/2014/main" id="{402BAA64-D8CE-4999-8C3C-DA5B5BBEE590}"/>
+                <a16:creationId xmlns:a16="http://schemas.microsoft.com/office/drawing/2014/main" id="{FE786731-758F-4DA8-99CF-FFEAAEF90458}"/>
               </a:ext>
             </a:extLst>
           </p:cNvPr>
@@ -3047,7 +3047,7 @@
           <p:cNvPr id="44" name="figure-one-source">
             <a:extLst xmlns:a="http://schemas.openxmlformats.org/drawingml/2006/main">
               <a:ext uri="{FF2B5EF4-FFF2-40B4-BE49-F238E27FC236}">
-                <a16:creationId xmlns:a16="http://schemas.microsoft.com/office/drawing/2014/main" id="{CA8306D2-7BBC-40B5-89BD-F8A089BAA12E}"/>
+                <a16:creationId xmlns:a16="http://schemas.microsoft.com/office/drawing/2014/main" id="{4EEE8B35-B974-4D33-8026-411AF6655EA6}"/>
               </a:ext>
             </a:extLst>
           </p:cNvPr>
@@ -3097,7 +3097,7 @@
           <p:cNvPr id="45" name="central-takeaway">
             <a:extLst xmlns:a="http://schemas.openxmlformats.org/drawingml/2006/main">
               <a:ext uri="{FF2B5EF4-FFF2-40B4-BE49-F238E27FC236}">
-                <a16:creationId xmlns:a16="http://schemas.microsoft.com/office/drawing/2014/main" id="{70D48499-137D-4ADE-A015-0A2A479EC252}"/>
+                <a16:creationId xmlns:a16="http://schemas.microsoft.com/office/drawing/2014/main" id="{F808D64D-82FD-4133-B8E2-1098CC2F1B3F}"/>
               </a:ext>
             </a:extLst>
           </p:cNvPr>
@@ -3130,7 +3130,7 @@
           <p:cNvPr id="46" name="central-takeaway-title">
             <a:extLst xmlns:a="http://schemas.openxmlformats.org/drawingml/2006/main">
               <a:ext uri="{FF2B5EF4-FFF2-40B4-BE49-F238E27FC236}">
-                <a16:creationId xmlns:a16="http://schemas.microsoft.com/office/drawing/2014/main" id="{432A35DB-C1AD-4B98-938F-FD99FD46EA36}"/>
+                <a16:creationId xmlns:a16="http://schemas.microsoft.com/office/drawing/2014/main" id="{EE7603D6-2F83-4338-B137-1E00DB684DB0}"/>
               </a:ext>
             </a:extLst>
           </p:cNvPr>
@@ -3180,7 +3180,7 @@
           <p:cNvPr id="47" name="central-takeaway-subtitle">
             <a:extLst xmlns:a="http://schemas.openxmlformats.org/drawingml/2006/main">
               <a:ext uri="{FF2B5EF4-FFF2-40B4-BE49-F238E27FC236}">
-                <a16:creationId xmlns:a16="http://schemas.microsoft.com/office/drawing/2014/main" id="{CC7F2F87-18C7-45BB-B3FB-48D5B2B9687D}"/>
+                <a16:creationId xmlns:a16="http://schemas.microsoft.com/office/drawing/2014/main" id="{520FA040-E5E5-4CA8-B34E-99C97660A460}"/>
               </a:ext>
             </a:extLst>
           </p:cNvPr>
@@ -3230,7 +3230,7 @@
           <p:cNvPr id="48" name="takeaway-evidence">
             <a:extLst xmlns:a="http://schemas.openxmlformats.org/drawingml/2006/main">
               <a:ext uri="{FF2B5EF4-FFF2-40B4-BE49-F238E27FC236}">
-                <a16:creationId xmlns:a16="http://schemas.microsoft.com/office/drawing/2014/main" id="{8A274370-DF51-4AD0-902A-7771A76D62B7}"/>
+                <a16:creationId xmlns:a16="http://schemas.microsoft.com/office/drawing/2014/main" id="{52CA42D6-D990-4A0A-8FD0-D1A1686FDCA1}"/>
               </a:ext>
             </a:extLst>
           </p:cNvPr>
@@ -3280,7 +3280,7 @@
           <p:cNvPr id="49" name="figure-two-heading-title">
             <a:extLst xmlns:a="http://schemas.openxmlformats.org/drawingml/2006/main">
               <a:ext uri="{FF2B5EF4-FFF2-40B4-BE49-F238E27FC236}">
-                <a16:creationId xmlns:a16="http://schemas.microsoft.com/office/drawing/2014/main" id="{754B1541-1E94-4BEF-AD32-0EB94B121340}"/>
+                <a16:creationId xmlns:a16="http://schemas.microsoft.com/office/drawing/2014/main" id="{4F46CAC8-125D-4140-A213-7BA43D57CBF3}"/>
               </a:ext>
             </a:extLst>
           </p:cNvPr>
@@ -3330,7 +3330,7 @@
           <p:cNvPr id="50" name="figure-two-heading-rule">
             <a:extLst xmlns:a="http://schemas.openxmlformats.org/drawingml/2006/main">
               <a:ext uri="{FF2B5EF4-FFF2-40B4-BE49-F238E27FC236}">
-                <a16:creationId xmlns:a16="http://schemas.microsoft.com/office/drawing/2014/main" id="{564B9B79-4AF7-412E-B35C-8FD4CF9F3A4C}"/>
+                <a16:creationId xmlns:a16="http://schemas.microsoft.com/office/drawing/2014/main" id="{CFD2E33D-FE06-45EC-93A5-7D9D8AD15EA7}"/>
               </a:ext>
             </a:extLst>
           </p:cNvPr>
@@ -3363,7 +3363,7 @@
           <p:cNvPr id="51" name="figure-two-frame">
             <a:extLst xmlns:a="http://schemas.openxmlformats.org/drawingml/2006/main">
               <a:ext uri="{FF2B5EF4-FFF2-40B4-BE49-F238E27FC236}">
-                <a16:creationId xmlns:a16="http://schemas.microsoft.com/office/drawing/2014/main" id="{460A41D7-1655-41F6-99BE-BCD179EC2157}"/>
+                <a16:creationId xmlns:a16="http://schemas.microsoft.com/office/drawing/2014/main" id="{2FD65C67-F6EB-4E20-8653-8F97B2EF3405}"/>
               </a:ext>
             </a:extLst>
           </p:cNvPr>
@@ -3398,7 +3398,7 @@
           <p:cNvPr id="52" name="figure-two-placeholder">
             <a:extLst xmlns:a="http://schemas.openxmlformats.org/drawingml/2006/main">
               <a:ext uri="{FF2B5EF4-FFF2-40B4-BE49-F238E27FC236}">
-                <a16:creationId xmlns:a16="http://schemas.microsoft.com/office/drawing/2014/main" id="{1CA078C4-A198-478D-A1F7-852ECBDD868A}"/>
+                <a16:creationId xmlns:a16="http://schemas.microsoft.com/office/drawing/2014/main" id="{7345368A-B996-40CA-AFDD-D8F051A22B9B}"/>
               </a:ext>
             </a:extLst>
           </p:cNvPr>
@@ -3433,7 +3433,7 @@
           <p:cNvPr id="53" name="figure-two-placeholder-label">
             <a:extLst xmlns:a="http://schemas.openxmlformats.org/drawingml/2006/main">
               <a:ext uri="{FF2B5EF4-FFF2-40B4-BE49-F238E27FC236}">
-                <a16:creationId xmlns:a16="http://schemas.microsoft.com/office/drawing/2014/main" id="{663AD537-7298-48FD-B231-D1BA682C9FAC}"/>
+                <a16:creationId xmlns:a16="http://schemas.microsoft.com/office/drawing/2014/main" id="{97F49522-A8E5-4E49-9696-E796EE3EA6D7}"/>
               </a:ext>
             </a:extLst>
           </p:cNvPr>
@@ -3483,7 +3483,7 @@
           <p:cNvPr id="54" name="figure-two-caption">
             <a:extLst xmlns:a="http://schemas.openxmlformats.org/drawingml/2006/main">
               <a:ext uri="{FF2B5EF4-FFF2-40B4-BE49-F238E27FC236}">
-                <a16:creationId xmlns:a16="http://schemas.microsoft.com/office/drawing/2014/main" id="{9CA39949-ADF0-48A8-9FC1-B229D05C3DD4}"/>
+                <a16:creationId xmlns:a16="http://schemas.microsoft.com/office/drawing/2014/main" id="{4831CCB0-B2C0-4D66-A1FE-FD374CCFED57}"/>
               </a:ext>
             </a:extLst>
           </p:cNvPr>
@@ -3533,7 +3533,7 @@
           <p:cNvPr id="55" name="figure-two-source">
             <a:extLst xmlns:a="http://schemas.openxmlformats.org/drawingml/2006/main">
               <a:ext uri="{FF2B5EF4-FFF2-40B4-BE49-F238E27FC236}">
-                <a16:creationId xmlns:a16="http://schemas.microsoft.com/office/drawing/2014/main" id="{9387621A-E126-4438-A928-43EF3C6F818C}"/>
+                <a16:creationId xmlns:a16="http://schemas.microsoft.com/office/drawing/2014/main" id="{DCB54A76-405A-4592-9352-460BDE72A878}"/>
               </a:ext>
             </a:extLst>
           </p:cNvPr>
@@ -3583,7 +3583,7 @@
           <p:cNvPr id="56" name="validation-heading-title">
             <a:extLst xmlns:a="http://schemas.openxmlformats.org/drawingml/2006/main">
               <a:ext uri="{FF2B5EF4-FFF2-40B4-BE49-F238E27FC236}">
-                <a16:creationId xmlns:a16="http://schemas.microsoft.com/office/drawing/2014/main" id="{99FE46EA-0D32-4938-A906-4F371C6F5DB6}"/>
+                <a16:creationId xmlns:a16="http://schemas.microsoft.com/office/drawing/2014/main" id="{19FE260E-2FD2-4D16-B61F-D60721C9AED4}"/>
               </a:ext>
             </a:extLst>
           </p:cNvPr>
@@ -3633,7 +3633,7 @@
           <p:cNvPr id="57" name="validation-heading-rule">
             <a:extLst xmlns:a="http://schemas.openxmlformats.org/drawingml/2006/main">
               <a:ext uri="{FF2B5EF4-FFF2-40B4-BE49-F238E27FC236}">
-                <a16:creationId xmlns:a16="http://schemas.microsoft.com/office/drawing/2014/main" id="{95FE1D30-D6BD-4131-B150-B79A7BB3C9EE}"/>
+                <a16:creationId xmlns:a16="http://schemas.microsoft.com/office/drawing/2014/main" id="{3AA8E295-97D0-48F2-A2EE-76F0DE2C6220}"/>
               </a:ext>
             </a:extLst>
           </p:cNvPr>
@@ -3666,7 +3666,7 @@
           <p:cNvPr id="58" name="validation-panel">
             <a:extLst xmlns:a="http://schemas.openxmlformats.org/drawingml/2006/main">
               <a:ext uri="{FF2B5EF4-FFF2-40B4-BE49-F238E27FC236}">
-                <a16:creationId xmlns:a16="http://schemas.microsoft.com/office/drawing/2014/main" id="{E74AAA6B-443E-44D7-B85F-443976A45FA7}"/>
+                <a16:creationId xmlns:a16="http://schemas.microsoft.com/office/drawing/2014/main" id="{78DFC1D6-E808-447E-B732-3240CCEA8961}"/>
               </a:ext>
             </a:extLst>
           </p:cNvPr>
@@ -3701,7 +3701,7 @@
           <p:cNvPr id="59" name="validation">
             <a:extLst xmlns:a="http://schemas.openxmlformats.org/drawingml/2006/main">
               <a:ext uri="{FF2B5EF4-FFF2-40B4-BE49-F238E27FC236}">
-                <a16:creationId xmlns:a16="http://schemas.microsoft.com/office/drawing/2014/main" id="{8609574C-4B95-45FC-BBD1-2889D3F8DCB0}"/>
+                <a16:creationId xmlns:a16="http://schemas.microsoft.com/office/drawing/2014/main" id="{7584C1AA-87FE-4BCF-82B4-D7D5B81F046C}"/>
               </a:ext>
             </a:extLst>
           </p:cNvPr>
@@ -3785,7 +3785,7 @@
           <p:cNvPr id="60" name="validation-evidence">
             <a:extLst xmlns:a="http://schemas.openxmlformats.org/drawingml/2006/main">
               <a:ext uri="{FF2B5EF4-FFF2-40B4-BE49-F238E27FC236}">
-                <a16:creationId xmlns:a16="http://schemas.microsoft.com/office/drawing/2014/main" id="{CA4059B0-F9C0-4C23-A7D0-1F7B87A02F0B}"/>
+                <a16:creationId xmlns:a16="http://schemas.microsoft.com/office/drawing/2014/main" id="{7572D798-6BE7-4111-8067-9701F4EE6DD3}"/>
               </a:ext>
             </a:extLst>
           </p:cNvPr>
@@ -3835,7 +3835,7 @@
           <p:cNvPr id="61" name="performance-strip">
             <a:extLst xmlns:a="http://schemas.openxmlformats.org/drawingml/2006/main">
               <a:ext uri="{FF2B5EF4-FFF2-40B4-BE49-F238E27FC236}">
-                <a16:creationId xmlns:a16="http://schemas.microsoft.com/office/drawing/2014/main" id="{E667F02D-1179-41A4-8787-586E641FD3DC}"/>
+                <a16:creationId xmlns:a16="http://schemas.microsoft.com/office/drawing/2014/main" id="{A4764D25-6C26-48E7-A1F8-A58F3CC8178D}"/>
               </a:ext>
             </a:extLst>
           </p:cNvPr>
@@ -3868,7 +3868,7 @@
           <p:cNvPr id="62" name="performance-strip-text">
             <a:extLst xmlns:a="http://schemas.openxmlformats.org/drawingml/2006/main">
               <a:ext uri="{FF2B5EF4-FFF2-40B4-BE49-F238E27FC236}">
-                <a16:creationId xmlns:a16="http://schemas.microsoft.com/office/drawing/2014/main" id="{6C110113-E3E1-4B52-B356-C617136BEA4B}"/>
+                <a16:creationId xmlns:a16="http://schemas.microsoft.com/office/drawing/2014/main" id="{7EB3169B-B28E-49FE-A61D-9A9E18BA79FF}"/>
               </a:ext>
             </a:extLst>
           </p:cNvPr>
@@ -3918,7 +3918,7 @@
           <p:cNvPr id="63" name="biology-heading-title">
             <a:extLst xmlns:a="http://schemas.openxmlformats.org/drawingml/2006/main">
               <a:ext uri="{FF2B5EF4-FFF2-40B4-BE49-F238E27FC236}">
-                <a16:creationId xmlns:a16="http://schemas.microsoft.com/office/drawing/2014/main" id="{BCD6204B-55EA-4FAA-B1CF-3F201AE7E41B}"/>
+                <a16:creationId xmlns:a16="http://schemas.microsoft.com/office/drawing/2014/main" id="{52AD9FD2-95B3-4017-82DF-89D9696C93D5}"/>
               </a:ext>
             </a:extLst>
           </p:cNvPr>
@@ -3968,7 +3968,7 @@
           <p:cNvPr id="64" name="biology-heading-rule">
             <a:extLst xmlns:a="http://schemas.openxmlformats.org/drawingml/2006/main">
               <a:ext uri="{FF2B5EF4-FFF2-40B4-BE49-F238E27FC236}">
-                <a16:creationId xmlns:a16="http://schemas.microsoft.com/office/drawing/2014/main" id="{CA1DB453-D2C8-4DF6-828D-E9C3FE500785}"/>
+                <a16:creationId xmlns:a16="http://schemas.microsoft.com/office/drawing/2014/main" id="{69CEFE59-2B6E-482F-9CD9-2E07C00D0D3A}"/>
               </a:ext>
             </a:extLst>
           </p:cNvPr>
@@ -4001,7 +4001,7 @@
           <p:cNvPr id="65" name="biology-1-value">
             <a:extLst xmlns:a="http://schemas.openxmlformats.org/drawingml/2006/main">
               <a:ext uri="{FF2B5EF4-FFF2-40B4-BE49-F238E27FC236}">
-                <a16:creationId xmlns:a16="http://schemas.microsoft.com/office/drawing/2014/main" id="{00D05826-5C15-417E-8BCE-86F6FBC7C432}"/>
+                <a16:creationId xmlns:a16="http://schemas.microsoft.com/office/drawing/2014/main" id="{0BBA2AAD-6B8C-418D-9FB1-F758FA83729A}"/>
               </a:ext>
             </a:extLst>
           </p:cNvPr>
@@ -4051,7 +4051,7 @@
           <p:cNvPr id="66" name="biology-1-label">
             <a:extLst xmlns:a="http://schemas.openxmlformats.org/drawingml/2006/main">
               <a:ext uri="{FF2B5EF4-FFF2-40B4-BE49-F238E27FC236}">
-                <a16:creationId xmlns:a16="http://schemas.microsoft.com/office/drawing/2014/main" id="{EB086F74-DBB2-411E-A313-F68B466E5F58}"/>
+                <a16:creationId xmlns:a16="http://schemas.microsoft.com/office/drawing/2014/main" id="{0938CFFE-B19C-4F51-A878-836F3C1C50B7}"/>
               </a:ext>
             </a:extLst>
           </p:cNvPr>
@@ -4101,7 +4101,7 @@
           <p:cNvPr id="67" name="biology-2-value">
             <a:extLst xmlns:a="http://schemas.openxmlformats.org/drawingml/2006/main">
               <a:ext uri="{FF2B5EF4-FFF2-40B4-BE49-F238E27FC236}">
-                <a16:creationId xmlns:a16="http://schemas.microsoft.com/office/drawing/2014/main" id="{2FD79E52-99EA-45F5-8AD9-E03D7D922066}"/>
+                <a16:creationId xmlns:a16="http://schemas.microsoft.com/office/drawing/2014/main" id="{D4A70663-0A64-428E-887A-FA5C7574A48F}"/>
               </a:ext>
             </a:extLst>
           </p:cNvPr>
@@ -4151,7 +4151,7 @@
           <p:cNvPr id="68" name="biology-2-label">
             <a:extLst xmlns:a="http://schemas.openxmlformats.org/drawingml/2006/main">
               <a:ext uri="{FF2B5EF4-FFF2-40B4-BE49-F238E27FC236}">
-                <a16:creationId xmlns:a16="http://schemas.microsoft.com/office/drawing/2014/main" id="{9AC010ED-4246-42F4-89EE-AE1FCFDC504B}"/>
+                <a16:creationId xmlns:a16="http://schemas.microsoft.com/office/drawing/2014/main" id="{1984FF37-EA4E-41C0-80AF-429B0525BE93}"/>
               </a:ext>
             </a:extLst>
           </p:cNvPr>
@@ -4201,7 +4201,7 @@
           <p:cNvPr id="69" name="biology-3-value">
             <a:extLst xmlns:a="http://schemas.openxmlformats.org/drawingml/2006/main">
               <a:ext uri="{FF2B5EF4-FFF2-40B4-BE49-F238E27FC236}">
-                <a16:creationId xmlns:a16="http://schemas.microsoft.com/office/drawing/2014/main" id="{33D2B83B-EF92-42BF-98BE-142EFEF80ECA}"/>
+                <a16:creationId xmlns:a16="http://schemas.microsoft.com/office/drawing/2014/main" id="{66A93584-B5FD-4848-9460-EB4681F2C27C}"/>
               </a:ext>
             </a:extLst>
           </p:cNvPr>
@@ -4251,7 +4251,7 @@
           <p:cNvPr id="70" name="biology-3-label">
             <a:extLst xmlns:a="http://schemas.openxmlformats.org/drawingml/2006/main">
               <a:ext uri="{FF2B5EF4-FFF2-40B4-BE49-F238E27FC236}">
-                <a16:creationId xmlns:a16="http://schemas.microsoft.com/office/drawing/2014/main" id="{373F87DB-9501-406F-AD25-D2E1C7BC30D2}"/>
+                <a16:creationId xmlns:a16="http://schemas.microsoft.com/office/drawing/2014/main" id="{7D15C167-3082-4225-B237-4653E4F90FB1}"/>
               </a:ext>
             </a:extLst>
           </p:cNvPr>
@@ -4301,7 +4301,7 @@
           <p:cNvPr id="71" name="biology-evidence">
             <a:extLst xmlns:a="http://schemas.openxmlformats.org/drawingml/2006/main">
               <a:ext uri="{FF2B5EF4-FFF2-40B4-BE49-F238E27FC236}">
-                <a16:creationId xmlns:a16="http://schemas.microsoft.com/office/drawing/2014/main" id="{EF87E9F3-E477-4D88-A39C-5A7757DCC8BB}"/>
+                <a16:creationId xmlns:a16="http://schemas.microsoft.com/office/drawing/2014/main" id="{840AEC64-C203-4344-AB03-3C5A4F41E859}"/>
               </a:ext>
             </a:extLst>
           </p:cNvPr>
@@ -4351,7 +4351,7 @@
           <p:cNvPr id="72" name="figure-three-frame">
             <a:extLst xmlns:a="http://schemas.openxmlformats.org/drawingml/2006/main">
               <a:ext uri="{FF2B5EF4-FFF2-40B4-BE49-F238E27FC236}">
-                <a16:creationId xmlns:a16="http://schemas.microsoft.com/office/drawing/2014/main" id="{65BA3DFA-CE9E-45F9-B351-BC3DCAAB6F5D}"/>
+                <a16:creationId xmlns:a16="http://schemas.microsoft.com/office/drawing/2014/main" id="{48E8D3AF-DCB3-47F6-B6BE-C7259C2912D3}"/>
               </a:ext>
             </a:extLst>
           </p:cNvPr>
@@ -4386,7 +4386,7 @@
           <p:cNvPr id="73" name="figure-three-placeholder">
             <a:extLst xmlns:a="http://schemas.openxmlformats.org/drawingml/2006/main">
               <a:ext uri="{FF2B5EF4-FFF2-40B4-BE49-F238E27FC236}">
-                <a16:creationId xmlns:a16="http://schemas.microsoft.com/office/drawing/2014/main" id="{B07ED656-45A7-457D-847A-CB584DD396A7}"/>
+                <a16:creationId xmlns:a16="http://schemas.microsoft.com/office/drawing/2014/main" id="{6E7D7F95-36EC-4101-BA9D-07BD491DE91D}"/>
               </a:ext>
             </a:extLst>
           </p:cNvPr>
@@ -4421,7 +4421,7 @@
           <p:cNvPr id="74" name="figure-three-placeholder-label">
             <a:extLst xmlns:a="http://schemas.openxmlformats.org/drawingml/2006/main">
               <a:ext uri="{FF2B5EF4-FFF2-40B4-BE49-F238E27FC236}">
-                <a16:creationId xmlns:a16="http://schemas.microsoft.com/office/drawing/2014/main" id="{03C5B580-6A01-4F82-AB31-638489B76053}"/>
+                <a16:creationId xmlns:a16="http://schemas.microsoft.com/office/drawing/2014/main" id="{EBCFCC3C-23DE-41DA-B879-BC677A428C3E}"/>
               </a:ext>
             </a:extLst>
           </p:cNvPr>
@@ -4471,7 +4471,7 @@
           <p:cNvPr id="75" name="figure-three-caption">
             <a:extLst xmlns:a="http://schemas.openxmlformats.org/drawingml/2006/main">
               <a:ext uri="{FF2B5EF4-FFF2-40B4-BE49-F238E27FC236}">
-                <a16:creationId xmlns:a16="http://schemas.microsoft.com/office/drawing/2014/main" id="{E9C8143B-0B54-4019-A389-613803198FC6}"/>
+                <a16:creationId xmlns:a16="http://schemas.microsoft.com/office/drawing/2014/main" id="{9CBD4085-AE2D-481A-9680-161B63F3A2A3}"/>
               </a:ext>
             </a:extLst>
           </p:cNvPr>
@@ -4521,7 +4521,7 @@
           <p:cNvPr id="76" name="figure-three-source">
             <a:extLst xmlns:a="http://schemas.openxmlformats.org/drawingml/2006/main">
               <a:ext uri="{FF2B5EF4-FFF2-40B4-BE49-F238E27FC236}">
-                <a16:creationId xmlns:a16="http://schemas.microsoft.com/office/drawing/2014/main" id="{F84DADA7-762C-45D7-B09B-31630EB57AD7}"/>
+                <a16:creationId xmlns:a16="http://schemas.microsoft.com/office/drawing/2014/main" id="{31ED88B3-506D-4F6D-AAEA-EE5DD971D707}"/>
               </a:ext>
             </a:extLst>
           </p:cNvPr>
@@ -4571,7 +4571,7 @@
           <p:cNvPr id="77" name="validation-visual-heading-title">
             <a:extLst xmlns:a="http://schemas.openxmlformats.org/drawingml/2006/main">
               <a:ext uri="{FF2B5EF4-FFF2-40B4-BE49-F238E27FC236}">
-                <a16:creationId xmlns:a16="http://schemas.microsoft.com/office/drawing/2014/main" id="{AE12039E-13F0-4C10-AAB0-5A8379D28638}"/>
+                <a16:creationId xmlns:a16="http://schemas.microsoft.com/office/drawing/2014/main" id="{7DF85E32-75F8-4061-A79D-45B783D8A85B}"/>
               </a:ext>
             </a:extLst>
           </p:cNvPr>
@@ -4621,7 +4621,7 @@
           <p:cNvPr id="78" name="validation-visual-heading-rule">
             <a:extLst xmlns:a="http://schemas.openxmlformats.org/drawingml/2006/main">
               <a:ext uri="{FF2B5EF4-FFF2-40B4-BE49-F238E27FC236}">
-                <a16:creationId xmlns:a16="http://schemas.microsoft.com/office/drawing/2014/main" id="{9B0A7F53-BAF6-4705-8511-68B7FC3792E1}"/>
+                <a16:creationId xmlns:a16="http://schemas.microsoft.com/office/drawing/2014/main" id="{4CE15F0B-FC5E-450D-BC28-B6DAEC938E0B}"/>
               </a:ext>
             </a:extLst>
           </p:cNvPr>
@@ -4654,7 +4654,7 @@
           <p:cNvPr id="79" name="figure-four-frame">
             <a:extLst xmlns:a="http://schemas.openxmlformats.org/drawingml/2006/main">
               <a:ext uri="{FF2B5EF4-FFF2-40B4-BE49-F238E27FC236}">
-                <a16:creationId xmlns:a16="http://schemas.microsoft.com/office/drawing/2014/main" id="{C9F8AEFC-8A2A-4391-B06C-5E8DC20F25EC}"/>
+                <a16:creationId xmlns:a16="http://schemas.microsoft.com/office/drawing/2014/main" id="{62B16923-F70A-4F27-92EF-30A0EC803C8F}"/>
               </a:ext>
             </a:extLst>
           </p:cNvPr>
@@ -4689,7 +4689,7 @@
           <p:cNvPr id="80" name="figure-four-placeholder">
             <a:extLst xmlns:a="http://schemas.openxmlformats.org/drawingml/2006/main">
               <a:ext uri="{FF2B5EF4-FFF2-40B4-BE49-F238E27FC236}">
-                <a16:creationId xmlns:a16="http://schemas.microsoft.com/office/drawing/2014/main" id="{56761F03-34C8-4311-A764-3613EF8F9C8E}"/>
+                <a16:creationId xmlns:a16="http://schemas.microsoft.com/office/drawing/2014/main" id="{88D2164E-1E46-46A6-A5B7-DC8DC89B15C9}"/>
               </a:ext>
             </a:extLst>
           </p:cNvPr>
@@ -4724,7 +4724,7 @@
           <p:cNvPr id="81" name="figure-four-placeholder-label">
             <a:extLst xmlns:a="http://schemas.openxmlformats.org/drawingml/2006/main">
               <a:ext uri="{FF2B5EF4-FFF2-40B4-BE49-F238E27FC236}">
-                <a16:creationId xmlns:a16="http://schemas.microsoft.com/office/drawing/2014/main" id="{8AB5D2C1-3150-47CC-A5A5-17DF544E6E39}"/>
+                <a16:creationId xmlns:a16="http://schemas.microsoft.com/office/drawing/2014/main" id="{4A87CF42-5736-4476-A596-19602206FB4D}"/>
               </a:ext>
             </a:extLst>
           </p:cNvPr>
@@ -4774,7 +4774,7 @@
           <p:cNvPr id="82" name="figure-four-caption">
             <a:extLst xmlns:a="http://schemas.openxmlformats.org/drawingml/2006/main">
               <a:ext uri="{FF2B5EF4-FFF2-40B4-BE49-F238E27FC236}">
-                <a16:creationId xmlns:a16="http://schemas.microsoft.com/office/drawing/2014/main" id="{E3B493A1-2B2E-4505-B7D7-D48D5DBE9E61}"/>
+                <a16:creationId xmlns:a16="http://schemas.microsoft.com/office/drawing/2014/main" id="{6B257C2D-CC70-4796-8F42-95D3A8E80A5E}"/>
               </a:ext>
             </a:extLst>
           </p:cNvPr>
@@ -4824,7 +4824,7 @@
           <p:cNvPr id="83" name="figure-four-source">
             <a:extLst xmlns:a="http://schemas.openxmlformats.org/drawingml/2006/main">
               <a:ext uri="{FF2B5EF4-FFF2-40B4-BE49-F238E27FC236}">
-                <a16:creationId xmlns:a16="http://schemas.microsoft.com/office/drawing/2014/main" id="{DEB798FF-CF35-4EB9-9290-1FA2951D5BEC}"/>
+                <a16:creationId xmlns:a16="http://schemas.microsoft.com/office/drawing/2014/main" id="{E36AF510-CE23-44CF-9B2A-4E5D3FF75270}"/>
               </a:ext>
             </a:extLst>
           </p:cNvPr>
@@ -4874,7 +4874,7 @@
           <p:cNvPr id="84" name="conclusion-heading-title">
             <a:extLst xmlns:a="http://schemas.openxmlformats.org/drawingml/2006/main">
               <a:ext uri="{FF2B5EF4-FFF2-40B4-BE49-F238E27FC236}">
-                <a16:creationId xmlns:a16="http://schemas.microsoft.com/office/drawing/2014/main" id="{22822756-B23E-442A-BE98-8C87688EE512}"/>
+                <a16:creationId xmlns:a16="http://schemas.microsoft.com/office/drawing/2014/main" id="{D7CA8C67-7650-4277-AF04-F55A4B0EA07B}"/>
               </a:ext>
             </a:extLst>
           </p:cNvPr>
@@ -4924,7 +4924,7 @@
           <p:cNvPr id="85" name="conclusion-heading-rule">
             <a:extLst xmlns:a="http://schemas.openxmlformats.org/drawingml/2006/main">
               <a:ext uri="{FF2B5EF4-FFF2-40B4-BE49-F238E27FC236}">
-                <a16:creationId xmlns:a16="http://schemas.microsoft.com/office/drawing/2014/main" id="{A3F5CA08-4366-4582-96CB-46D31EB1ECAA}"/>
+                <a16:creationId xmlns:a16="http://schemas.microsoft.com/office/drawing/2014/main" id="{0397BC4C-752F-4D6E-A2FA-D739AF164747}"/>
               </a:ext>
             </a:extLst>
           </p:cNvPr>
@@ -4957,7 +4957,7 @@
           <p:cNvPr id="86" name="conclusion-panel">
             <a:extLst xmlns:a="http://schemas.openxmlformats.org/drawingml/2006/main">
               <a:ext uri="{FF2B5EF4-FFF2-40B4-BE49-F238E27FC236}">
-                <a16:creationId xmlns:a16="http://schemas.microsoft.com/office/drawing/2014/main" id="{33F5B302-C0CD-438B-99CE-C034BE69F499}"/>
+                <a16:creationId xmlns:a16="http://schemas.microsoft.com/office/drawing/2014/main" id="{857B9AC0-14D9-4380-B66F-D438AF03B3F4}"/>
               </a:ext>
             </a:extLst>
           </p:cNvPr>
@@ -4992,7 +4992,7 @@
           <p:cNvPr id="87" name="conclusion">
             <a:extLst xmlns:a="http://schemas.openxmlformats.org/drawingml/2006/main">
               <a:ext uri="{FF2B5EF4-FFF2-40B4-BE49-F238E27FC236}">
-                <a16:creationId xmlns:a16="http://schemas.microsoft.com/office/drawing/2014/main" id="{72C3DE31-609D-493C-A0DC-0A8BEF4A50B2}"/>
+                <a16:creationId xmlns:a16="http://schemas.microsoft.com/office/drawing/2014/main" id="{874015C8-FDA0-4DDF-8664-7328C4F51BF0}"/>
               </a:ext>
             </a:extLst>
           </p:cNvPr>
@@ -5042,7 +5042,7 @@
           <p:cNvPr id="88" name="conclusion-evidence">
             <a:extLst xmlns:a="http://schemas.openxmlformats.org/drawingml/2006/main">
               <a:ext uri="{FF2B5EF4-FFF2-40B4-BE49-F238E27FC236}">
-                <a16:creationId xmlns:a16="http://schemas.microsoft.com/office/drawing/2014/main" id="{06147EC3-DB8B-48F8-B95D-157AA52DF9A5}"/>
+                <a16:creationId xmlns:a16="http://schemas.microsoft.com/office/drawing/2014/main" id="{B79C4170-C7A6-4C94-9281-D1E26EB3F93D}"/>
               </a:ext>
             </a:extLst>
           </p:cNvPr>
@@ -5092,7 +5092,7 @@
           <p:cNvPr id="89" name="footer-band">
             <a:extLst xmlns:a="http://schemas.openxmlformats.org/drawingml/2006/main">
               <a:ext uri="{FF2B5EF4-FFF2-40B4-BE49-F238E27FC236}">
-                <a16:creationId xmlns:a16="http://schemas.microsoft.com/office/drawing/2014/main" id="{A7D74331-DE92-4D0D-9E06-6A54DA78ECEA}"/>
+                <a16:creationId xmlns:a16="http://schemas.microsoft.com/office/drawing/2014/main" id="{9283DFBE-4C56-4CE1-BACB-0609E97E3774}"/>
               </a:ext>
             </a:extLst>
           </p:cNvPr>
@@ -5125,7 +5125,7 @@
           <p:cNvPr id="90" name="footer-source">
             <a:extLst xmlns:a="http://schemas.openxmlformats.org/drawingml/2006/main">
               <a:ext uri="{FF2B5EF4-FFF2-40B4-BE49-F238E27FC236}">
-                <a16:creationId xmlns:a16="http://schemas.microsoft.com/office/drawing/2014/main" id="{E488684B-ACDD-4998-9281-85578267232B}"/>
+                <a16:creationId xmlns:a16="http://schemas.microsoft.com/office/drawing/2014/main" id="{3EA411DA-30C6-4BB4-90B1-040E0E4064B1}"/>
               </a:ext>
             </a:extLst>
           </p:cNvPr>
@@ -5175,7 +5175,7 @@
           <p:cNvPr id="91" name="footer-status">
             <a:extLst xmlns:a="http://schemas.openxmlformats.org/drawingml/2006/main">
               <a:ext uri="{FF2B5EF4-FFF2-40B4-BE49-F238E27FC236}">
-                <a16:creationId xmlns:a16="http://schemas.microsoft.com/office/drawing/2014/main" id="{AEC4414C-A745-4A74-9665-AC029018AB91}"/>
+                <a16:creationId xmlns:a16="http://schemas.microsoft.com/office/drawing/2014/main" id="{E132A481-179D-4F28-8790-0A4B1226CBBE}"/>
               </a:ext>
             </a:extLst>
           </p:cNvPr>
@@ -5223,7 +5223,7 @@
     </p:spTree>
     <p:extLst>
       <p:ext uri="{BB962C8B-B14F-4D97-AF65-F5344CB8AC3E}">
-        <p14:creationId xmlns:p14="http://schemas.microsoft.com/office/powerpoint/2010/main" val="651772382"/>
+        <p14:creationId xmlns:p14="http://schemas.microsoft.com/office/powerpoint/2010/main" val="102969907"/>
       </p:ext>
     </p:extLst>
   </p:cSld>

</xml_diff>